<commit_message>
Stale ceilings: 43.4% is the 128px ladder's, and the deck now reports the 256px one
BEST uses 256px tiles, where the grid seam repair costs slightly more per pixel
and the ceiling is 42.5% rather than 43.4%. Several places had 43.4% written in.

theory.tex's Table 4 caption is corrected, and logconvex_check derives the figure
from the curve it was handed rather than printing a constant -- it was asserting
43.4% while analysing a 42.5% frontier.

The deck's cost slide keeps its numbers and says what they are. The MAC-vs-clock
agreement was timed on the 128px ladder, and what that slide checks is the cost
MODEL's fidelity, not this checkpoint's ceiling; leaving 43.4% next to a deck
that otherwise reports 42.5% would read as a contradiction. It now says which
ladder the timing came from and why the two differ.

Co-Authored-By: Claude Opus 5 <noreply@anthropic.com>
</commit_message>
<xml_diff>
--- a/paper/FLEX-UF_LMT.pptx
+++ b/paper/FLEX-UF_LMT.pptx
@@ -3279,7 +3279,7 @@
             <a:pPr/>
             <a:r>
               <a:rPr sz="1300" b="0"/>
-              <a:t>Saving falls with rate because early exit costs more there: the exit-2 penalty grows 4.3× from qp0 to qp63 as the latent carries more detail</a:t>
+              <a:t>Saving falls with rate because early exit costs more there: the exit-2 penalty grows 3.3× from qp0 to qp63 as the latent carries more detail</a:t>
             </a:r>
           </a:p>
           <a:p>
@@ -3573,7 +3573,7 @@
                   <a:srgbClr val="0065BD"/>
                 </a:solidFill>
               </a:rPr>
-              <a:t>Measured: Δ/J rises 0.91% → 6.86% with rate</a:t>
+              <a:t>Measured: Δ/J rises 0.39% → 2.09% with rate</a:t>
             </a:r>
           </a:p>
           <a:p>
@@ -4655,7 +4655,7 @@
         <p:spPr>
           <a:xfrm>
             <a:off x="508000" y="1417320"/>
-            <a:ext cx="8128000" cy="2446020"/>
+            <a:ext cx="8128000" cy="3169919"/>
           </a:xfrm>
         </p:spPr>
         <p:txBody>
@@ -4680,7 +4680,7 @@
                   <a:srgbClr val="0065BD"/>
                 </a:solidFill>
               </a:rPr>
-              <a:t>MACs are right for a paper and wrong for a promise, so wall-clock was measured on a 1080p decode:</a:t>
+              <a:t>MACs are right for a paper and wrong for a promise, so wall-clock was measured on a 1080p decode — on the 128px ladder, which is where the timing was taken:</a:t>
             </a:r>
           </a:p>
           <a:p>
@@ -4695,6 +4695,13 @@
             <a:r>
               <a:rPr sz="1000" b="0"/>
               <a:t>exit 3: 28.6% vs 28.8% · exit 4: 13.8% vs 14.9%</a:t>
+            </a:r>
+          </a:p>
+          <a:p>
+            <a:pPr lvl="1"/>
+            <a:r>
+              <a:rPr sz="1000" b="0"/>
+              <a:t>BEST uses 256px tiles, where the MAC ceiling is 42.5% rather than 43.4% — the grid seam repair scales with the tile, so the exit costs shift slightly. The agreement being checked here is the model's, not this checkpoint's.</a:t>
             </a:r>
           </a:p>
           <a:p>
@@ -4740,8 +4747,8 @@
         </p:blipFill>
         <p:spPr>
           <a:xfrm>
-            <a:off x="1444258" y="4027931"/>
-            <a:ext cx="6255483" cy="2418588"/>
+            <a:off x="2380413" y="4751832"/>
+            <a:ext cx="4383174" cy="1694687"/>
           </a:xfrm>
           <a:prstGeom prst="rect">
             <a:avLst/>

</xml_diff>

<commit_message>
The recipe slide now carries the anchor comparison from both runs' files
BEST -0.003 / -0.016 / -0.033 dB against VERBATIM's -0.146 / -0.153 / -0.217 at
qp 0/32/63, same architecture, same 256px tiles, same warm start, one epoch
each. VERBATIM's drift alone is 2.2x the 0.1 dB budget, so the target is
unreachable there at any saving.

Both numbers come from results/anchor_*.json, written by anchor_drift's new
--out and by the chain per run, so the slide cannot drift from the measurement.

Co-Authored-By: Claude Opus 5 <noreply@anthropic.com>
</commit_message>
<xml_diff>
--- a/paper/FLEX-UF_LMT.pptx
+++ b/paper/FLEX-UF_LMT.pptx
@@ -4107,7 +4107,7 @@
         <p:spPr>
           <a:xfrm>
             <a:off x="508000" y="1417320"/>
-            <a:ext cx="8128000" cy="3017520"/>
+            <a:ext cx="8128000" cy="3703320"/>
           </a:xfrm>
         </p:spPr>
         <p:txBody>
@@ -4160,7 +4160,7 @@
                   <a:srgbClr val="0065BD"/>
                 </a:solidFill>
               </a:rPr>
-              <a:t>anchor comparison pending VERBATIM's measurement</a:t>
+              <a:t>Deepest exit vs the release, same tiles and same warm start: BEST -0.003 / -0.016 / -0.033 dB against VERBATIM's -0.146 / -0.153 / -0.217 dB at qp0/32/63. VERBATIM's drift alone is 2.2× the 0.1 dB budget, so the target is unreachable there at any saving — the anchor term is a precondition, not a refinement</a:t>
             </a:r>
           </a:p>
           <a:p>
@@ -4217,8 +4217,8 @@
         </p:blipFill>
         <p:spPr>
           <a:xfrm>
-            <a:off x="1412597" y="4599431"/>
-            <a:ext cx="6318806" cy="1847088"/>
+            <a:off x="2585642" y="5285231"/>
+            <a:ext cx="3972715" cy="1161288"/>
           </a:xfrm>
           <a:prstGeom prst="rect">
             <a:avLst/>

</xml_diff>

<commit_message>
The recipe slide shows the collapse instead of describing it
The ladder-collapse finding went onto the slide as text and squeezed the figure
to nothing -- the slide was carrying three arguments (recipe verification, the
anchor evidence, the collapse) against one decorative learning-rate plot.

nf_collapse.png replaces that plot: CONTROL's per-exit dB before and after its
second epoch, at three rates. The shape is the whole argument -- the deepest
bar pair is level, every shallower pair opens up, and it opens wider the
shallower it is -- so the text that described the numbers is cut and the figure
carries them.

Figure and text now divide the work rather than duplicate it, which is also why
there is room for both. The recipe verification is one line: the evidence for it
is that verify_recipe.py exits non-zero on a mismatch, not a list of what it
checks.

Co-Authored-By: Claude Opus 5 <noreply@anthropic.com>
</commit_message>
<xml_diff>
--- a/paper/FLEX-UF_LMT.pptx
+++ b/paper/FLEX-UF_LMT.pptx
@@ -4107,7 +4107,7 @@
         <p:spPr>
           <a:xfrm>
             <a:off x="508000" y="1417320"/>
-            <a:ext cx="8128000" cy="4389120"/>
+            <a:ext cx="8128000" cy="3703320"/>
           </a:xfrm>
         </p:spPr>
         <p:txBody>
@@ -4125,34 +4125,6 @@
             </a:r>
           </a:p>
           <a:p>
-            <a:pPr lvl="1"/>
-            <a:r>
-              <a:rPr sz="900" b="0"/>
-              <a:t>8 schedule rows character for character · 106 entries</a:t>
-            </a:r>
-          </a:p>
-          <a:p>
-            <a:pPr lvl="1"/>
-            <a:r>
-              <a:rPr sz="900" b="0"/>
-              <a:t>AdamW 1e-4 · clip_grad_norm 0.1 · non-finite batch skipped</a:t>
-            </a:r>
-          </a:p>
-          <a:p>
-            <a:pPr lvl="1"/>
-            <a:r>
-              <a:rPr sz="900" b="0"/>
-              <a:t>ImageFolder + get_training_lambdas · 64 QP levels</a:t>
-            </a:r>
-          </a:p>
-          <a:p>
-            <a:pPr lvl="1"/>
-            <a:r>
-              <a:rPr sz="900" b="0"/>
-              <a:t>encoder identical over 74 tensors · 255 shared tensors, no shape change</a:t>
-            </a:r>
-          </a:p>
-          <a:p>
             <a:pPr/>
             <a:r>
               <a:rPr sz="1100" b="1">
@@ -4167,7 +4139,14 @@
             <a:pPr lvl="1"/>
             <a:r>
               <a:rPr sz="900" b="0"/>
-              <a:t>Saving at 0.1 dB across the three runs that share an architecture — anchor 0: unreachable at every rate; anchor 1: 14/12/9/7/5%; anchor 10: 35/31/27/24/22%. CONTROL→BEST changes four things at once, so that step is the bundle, not the anchor alone</a:t>
+              <a:t>Saving at 0.1 dB across the three runs that share an architecture — anchor 0: unreachable at every rate; anchor 1: 5/4/4/3/3%; anchor 10: 35/31/27/24/22%. CONTROL→BEST changes four things at once, so that step is the bundle, not the anchor alone</a:t>
+            </a:r>
+          </a:p>
+          <a:p>
+            <a:pPr lvl="1"/>
+            <a:r>
+              <a:rPr sz="900" b="0"/>
+              <a:t>CONTROL over its SECOND epoch, per-exit dB vs the release at qp63 (below): saving at 0.1 dB fell 14.1% → 4.7% at qp0. More training without the additions moves the ladder the wrong way, and the damage grows the shallower the exit</a:t>
             </a:r>
           </a:p>
           <a:p>
@@ -4178,21 +4157,7 @@
                   <a:srgbClr val="0065BD"/>
                 </a:solidFill>
               </a:rPr>
-              <a:t>Deliberate additions, listed rather than hidden:</a:t>
-            </a:r>
-          </a:p>
-          <a:p>
-            <a:pPr lvl="1"/>
-            <a:r>
-              <a:rPr sz="900" b="0"/>
-              <a:t>--epoch_offset (read the schedule where a warm start actually is)</a:t>
-            </a:r>
-          </a:p>
-          <a:p>
-            <a:pPr lvl="1"/>
-            <a:r>
-              <a:rPr sz="900" b="0"/>
-              <a:t>--anchor_weight, --new_lr_scale, --freeze_encoder</a:t>
+              <a:t>Deliberate additions, listed rather than hidden: --epoch_offset, --anchor_weight, --new_lr_scale, --freeze_encoder</a:t>
             </a:r>
           </a:p>
           <a:p>
@@ -4203,14 +4168,14 @@
                   <a:srgbClr val="0065BD"/>
                 </a:solidFill>
               </a:rPr>
-              <a:t>VERBATIM run: their final phase (epochs 90–104, 512px, lr 2e-4→1e-6) with NONE of those additions, effective batch 16 by accumulation</a:t>
+              <a:t>VERBATIM is their recipe with NONE of them, effective batch 16 by accumulation — the control both rows above are measured against</a:t>
             </a:r>
           </a:p>
         </p:txBody>
       </p:sp>
       <p:pic>
         <p:nvPicPr>
-          <p:cNvPr id="4" name="Picture 3" descr="nf_schedule.png"/>
+          <p:cNvPr id="4" name="Picture 3" descr="nf_collapse.png"/>
           <p:cNvPicPr>
             <a:picLocks noChangeAspect="1"/>
           </p:cNvPicPr>
@@ -4224,8 +4189,8 @@
         </p:blipFill>
         <p:spPr>
           <a:xfrm>
-            <a:off x="3320751" y="5971031"/>
-            <a:ext cx="2502497" cy="731520"/>
+            <a:off x="2401806" y="5285231"/>
+            <a:ext cx="4340388" cy="1161288"/>
           </a:xfrm>
           <a:prstGeom prst="rect">
             <a:avLst/>

</xml_diff>

<commit_message>
Take the withdrawn claim off the deck
The recipe slide said "more training without the additions moves the ladder the
wrong way", and the collapse figure was titled "CONTROL, no distillation or
scaled adapters: a second epoch degrades every exit except the deepest". Both
assert a cause that VERBATIM refuted an hour later -- it carries fewer additions
and every one of its exits improved over the same boundary.

Slide and figure now state the observation and say the cause is open, with
VERBATIM's contrast on the same line. Less tidy, and the only version that
survives its own evidence.

The measured facts are unchanged and stay: CONTROL's saving fell 14.1% to 4.7%
at qp0, the damage grows the shallower the exit, and VERBATIM did the opposite.

Co-Authored-By: Claude Opus 5 <noreply@anthropic.com>
</commit_message>
<xml_diff>
--- a/paper/FLEX-UF_LMT.pptx
+++ b/paper/FLEX-UF_LMT.pptx
@@ -4107,7 +4107,7 @@
         <p:spPr>
           <a:xfrm>
             <a:off x="508000" y="1417320"/>
-            <a:ext cx="8128000" cy="3703320"/>
+            <a:ext cx="8128000" cy="3931920"/>
           </a:xfrm>
         </p:spPr>
         <p:txBody>
@@ -4146,7 +4146,7 @@
             <a:pPr lvl="1"/>
             <a:r>
               <a:rPr sz="900" b="0"/>
-              <a:t>CONTROL over its SECOND epoch, per-exit dB vs the release at qp63 (below): saving at 0.1 dB fell 14.1% → 4.7% at qp0. More training without the additions moves the ladder the wrong way, and the damage grows the shallower the exit</a:t>
+              <a:t>CONTROL over its SECOND epoch, per-exit dB vs the release at qp63 (below): saving at 0.1 dB fell 14.1% → 4.7% at qp0, damage growing the shallower the exit. VERBATIM, which carries even less, IMPROVED over the same boundary — so this is CONTROL's, not 'training without the additions', and the cause is still open</a:t>
             </a:r>
           </a:p>
           <a:p>
@@ -4189,8 +4189,8 @@
         </p:blipFill>
         <p:spPr>
           <a:xfrm>
-            <a:off x="2401806" y="5285231"/>
-            <a:ext cx="4340388" cy="1161288"/>
+            <a:off x="2829009" y="5513831"/>
+            <a:ext cx="3485981" cy="932688"/>
           </a:xfrm>
           <a:prstGeom prst="rect">
             <a:avLst/>

</xml_diff>

<commit_message>
Quantisation gets a figure, and it disproves the caption I was about to write
Plotted the spread between shallowest and deepest exit against BOPs, since
the spread is the only thing a router can act on. Wrote '<=6 bit flattens
the ladder' as the panel title, then read the numbers: at qp63 the spread
goes 2.864 -> 1.398, but at qp0 it goes 0.704 -> 0.837. It rises. The
collapse is a high-rate effect and the general claim is false.

Title and slide now say that. Fifth time this session a mechanism claim
did not survive contact with the measurement it was summarising.
</commit_message>
<xml_diff>
--- a/paper/FLEX-UF_LMT.pptx
+++ b/paper/FLEX-UF_LMT.pptx
@@ -4946,102 +4946,120 @@
             <p:ph idx="1"/>
           </p:nvPr>
         </p:nvSpPr>
-        <p:spPr/>
+        <p:spPr>
+          <a:xfrm>
+            <a:off x="508000" y="1417320"/>
+            <a:ext cx="8128000" cy="2331720"/>
+          </a:xfrm>
+        </p:spPr>
         <p:txBody>
           <a:bodyPr/>
           <a:lstStyle/>
           <a:p>
             <a:pPr/>
             <a:r>
-              <a:rPr sz="1200" b="1">
-                <a:solidFill>
-                  <a:srgbClr val="0065BD"/>
-                </a:solidFill>
-              </a:rPr>
-              <a:t>Weight-only · per-channel · no calibration · decoder only (encoder would change the bitstream)</a:t>
-            </a:r>
-          </a:p>
-          <a:p>
-            <a:pPr/>
-            <a:r>
-              <a:rPr sz="1200" b="1">
-                <a:solidFill>
-                  <a:srgbClr val="0065BD"/>
-                </a:solidFill>
-              </a:rPr>
-              <a:t>Prediction registered: shallow exits suffer more. FALSIFIED.</a:t>
-            </a:r>
-          </a:p>
-          <a:p>
-            <a:pPr lvl="1"/>
-            <a:r>
-              <a:rPr sz="1000" b="0"/>
-              <a:t>qp 63, 8 bit:  exit 2 +0.108 dB   deepest +0.111 dB   ratio 0.97</a:t>
-            </a:r>
-          </a:p>
-          <a:p>
-            <a:pPr lvl="1"/>
-            <a:r>
-              <a:rPr sz="1000" b="0"/>
-              <a:t>6 and 4 bit: the DEEPEST exits suffer most</a:t>
-            </a:r>
-          </a:p>
-          <a:p>
-            <a:pPr/>
-            <a:r>
-              <a:rPr sz="1200" b="1">
-                <a:solidFill>
-                  <a:srgbClr val="0065BD"/>
-                </a:solidFill>
-              </a:rPr>
-              <a:t>Mechanism · the deepest exit starts at 0.073 dB and has no headroom to absorb a noise floor; a shallow exit's error already dominates</a:t>
-            </a:r>
-          </a:p>
-          <a:p>
-            <a:pPr/>
-            <a:r>
-              <a:rPr sz="1200" b="1">
-                <a:solidFill>
-                  <a:srgbClr val="0065BD"/>
-                </a:solidFill>
-              </a:rPr>
-              <a:t>What matters is the SPREAD — that is what routing exploits</a:t>
-            </a:r>
-          </a:p>
-          <a:p>
-            <a:pPr lvl="1"/>
-            <a:r>
-              <a:rPr sz="1000" b="0"/>
-              <a:t>qp 63:   fp32 2.864   →   8 bit 2.876   →   6 bit 2.224   →   4 bit 1.398</a:t>
-            </a:r>
-          </a:p>
-          <a:p>
-            <a:pPr lvl="1"/>
-            <a:r>
-              <a:rPr sz="1000" b="0"/>
-              <a:t>BOPs:    1.000        →   0.062        →   0.035        →   0.016</a:t>
-            </a:r>
-          </a:p>
-          <a:p>
-            <a:pPr/>
-            <a:r>
-              <a:rPr sz="1200" b="1">
-                <a:solidFill>
-                  <a:srgbClr val="0065BD"/>
-                </a:solidFill>
-              </a:rPr>
-              <a:t>8 bit composes cleanly at 16× fewer BOPs · ≤6 bit erodes the ladder</a:t>
-            </a:r>
-          </a:p>
-          <a:p>
-            <a:pPr lvl="1"/>
-            <a:r>
-              <a:rPr sz="1000" b="0"/>
+              <a:rPr sz="1100" b="1">
+                <a:solidFill>
+                  <a:srgbClr val="0065BD"/>
+                </a:solidFill>
+              </a:rPr>
+              <a:t>Weight-only · per-channel · no calibration · decoder only</a:t>
+            </a:r>
+          </a:p>
+          <a:p>
+            <a:pPr/>
+            <a:r>
+              <a:rPr sz="1100" b="1">
+                <a:solidFill>
+                  <a:srgbClr val="0065BD"/>
+                </a:solidFill>
+              </a:rPr>
+              <a:t>Registered prediction — shallow exits suffer more — FALSIFIED</a:t>
+            </a:r>
+          </a:p>
+          <a:p>
+            <a:pPr lvl="1"/>
+            <a:r>
+              <a:rPr sz="900" b="0"/>
+              <a:t>qp 63, 8 bit: exit 2 +0.108 dB, deepest +0.111 dB, ratio 0.97</a:t>
+            </a:r>
+          </a:p>
+          <a:p>
+            <a:pPr lvl="1"/>
+            <a:r>
+              <a:rPr sz="900" b="0"/>
+              <a:t>the deepest starts at 0.073 dB and has no headroom for a noise floor</a:t>
+            </a:r>
+          </a:p>
+          <a:p>
+            <a:pPr/>
+            <a:r>
+              <a:rPr sz="1100" b="1">
+                <a:solidFill>
+                  <a:srgbClr val="0065BD"/>
+                </a:solidFill>
+              </a:rPr>
+              <a:t>What matters is the SPREAD — the only thing a router can act on</a:t>
+            </a:r>
+          </a:p>
+          <a:p>
+            <a:pPr lvl="1"/>
+            <a:r>
+              <a:rPr sz="900" b="0"/>
+              <a:t>qp 63   fp32 2.864 → 8 b 2.876 → 6 b 2.224 → 4 b 1.398   ·   BOPs 1.000 → 0.062 → 0.035 → 0.016</a:t>
+            </a:r>
+          </a:p>
+          <a:p>
+            <a:pPr lvl="1"/>
+            <a:r>
+              <a:rPr sz="900" b="0"/>
+              <a:t>qp 0    0.704 → 0.712 → 0.791 → 0.837   — flat to rising, no collapse</a:t>
+            </a:r>
+          </a:p>
+          <a:p>
+            <a:pPr/>
+            <a:r>
+              <a:rPr sz="1100" b="1">
+                <a:solidFill>
+                  <a:srgbClr val="0065BD"/>
+                </a:solidFill>
+              </a:rPr>
+              <a:t>8 bit composes cleanly at 16× fewer BOPs · the collapse is a HIGH-RATE effect, not a general one</a:t>
+            </a:r>
+          </a:p>
+          <a:p>
+            <a:pPr lvl="1"/>
+            <a:r>
+              <a:rPr sz="900" b="0"/>
               <a:t>caveat: 8 bit still raises the floor 0.073 → 0.184 dB at qp 63</a:t>
             </a:r>
           </a:p>
         </p:txBody>
       </p:sp>
+      <p:pic>
+        <p:nvPicPr>
+          <p:cNvPr id="4" name="Picture 3" descr="quant.png"/>
+          <p:cNvPicPr>
+            <a:picLocks noChangeAspect="1"/>
+          </p:cNvPicPr>
+          <p:nvPr/>
+        </p:nvPicPr>
+        <p:blipFill>
+          <a:blip r:embed="rId2"/>
+          <a:stretch>
+            <a:fillRect/>
+          </a:stretch>
+        </p:blipFill>
+        <p:spPr>
+          <a:xfrm>
+            <a:off x="678991" y="3913631"/>
+            <a:ext cx="7786018" cy="2532888"/>
+          </a:xfrm>
+          <a:prstGeom prst="rect">
+            <a:avLst/>
+          </a:prstGeom>
+        </p:spPr>
+      </p:pic>
     </p:spTree>
   </p:cSld>
   <p:clrMapOvr>

</xml_diff>

<commit_message>
'The router collapsed' was too general -- three routers, three outcomes
Asked whether the router works, and the honest answer is yes: what collapsed
was BEST's, trained jointly with a moving decoder. Routing as such is fine.

  BEST, joint     collapsed to a qp-dependent constant, agreement 0.000 at qp63
  FINE12, joint   did NOT collapse -- budget met at every rate, beta ~ -0.01
  frozen retrain  0.848-0.923 agreement, budget met at every rate

So joint training is not automatically fatal either; FINE12 does it and
survives. Why BEST's collapsed and FINE12's did not is open -- they differ in
K, j, tile size and adapter kind, so the comparison isolates nothing.

Deck slide and docs/04 now put the three side by side instead of saying
routers collapse. PDF regenerated.
</commit_message>
<xml_diff>
--- a/paper/FLEX-UF_LMT.pptx
+++ b/paper/FLEX-UF_LMT.pptx
@@ -5435,7 +5435,7 @@
         <p:spPr>
           <a:xfrm>
             <a:off x="508000" y="1417320"/>
-            <a:ext cx="8128000" cy="1722120"/>
+            <a:ext cx="8128000" cy="2928619"/>
           </a:xfrm>
         </p:spPr>
         <p:txBody>
@@ -5456,7 +5456,7 @@
             <a:pPr lvl="1"/>
             <a:r>
               <a:rPr sz="1000" b="0"/>
-              <a:t>router trained JOINTLY with a moving decoder → collapsed, agreement 0.000 at qp 63</a:t>
+              <a:t>that was ONE router — BEST's, trained jointly with a moving decoder — not routing as such. Agreement 0.000 at qp 63, 239 of 240 tiles to one exit</a:t>
             </a:r>
           </a:p>
           <a:p>
@@ -5467,14 +5467,35 @@
                   <a:srgbClr val="0065BD"/>
                 </a:solidFill>
               </a:rPr>
-              <a:t>Retrained against the FROZEN decoder: 0.848 agreement, budget met at every rate</a:t>
+              <a:t>Routing works. Three routers, three outcomes:</a:t>
             </a:r>
           </a:p>
           <a:p>
             <a:pPr lvl="1"/>
             <a:r>
               <a:rPr sz="1000" b="0"/>
-              <a:t>⇒ the limit was the training target, not the information</a:t>
+              <a:t>BEST, joint          collapsed to a qp-dependent constant</a:t>
+            </a:r>
+          </a:p>
+          <a:p>
+            <a:pPr lvl="1"/>
+            <a:r>
+              <a:rPr sz="1000" b="0"/>
+              <a:t>FINE12, joint        did NOT collapse · budget met, β ≈ −0.01</a:t>
+            </a:r>
+          </a:p>
+          <a:p>
+            <a:pPr lvl="1"/>
+            <a:r>
+              <a:rPr sz="1000" b="0"/>
+              <a:t>retrained on FROZEN  0.848–0.923 agreement · budget met at every rate</a:t>
+            </a:r>
+          </a:p>
+          <a:p>
+            <a:pPr lvl="1"/>
+            <a:r>
+              <a:rPr sz="1000" b="0"/>
+              <a:t>⇒ the limit was the training target, not the information — and joint training does not always break it, which is itself unexplained</a:t>
             </a:r>
           </a:p>
           <a:p>
@@ -5513,8 +5534,8 @@
         </p:blipFill>
         <p:spPr>
           <a:xfrm>
-            <a:off x="411480" y="3304032"/>
-            <a:ext cx="8321039" cy="2827166"/>
+            <a:off x="1722958" y="4510531"/>
+            <a:ext cx="5698083" cy="1935987"/>
           </a:xfrm>
           <a:prstGeom prst="rect">
             <a:avLst/>

</xml_diff>